<commit_message>
docs(cnc): publish Euskara PPTX and PDF
</commit_message>
<xml_diff>
--- a/01_Erronka1_CNC_Guard/soluzioak/Presentacion_Tecnologias/CNC_Guard_Tecnologias_EU.pptx
+++ b/01_Erronka1_CNC_Guard/soluzioak/Presentacion_Tecnologias/CNC_Guard_Tecnologias_EU.pptx
@@ -5896,7 +5896,7 @@
               </a:defRPr>
             </a:pPr>
             <a:r>
-              <a:t>CNC GUARD / PROPUESTA TECNOLÓGICA</a:t>
+              <a:t>CNC GUARD / PROPOSAMEN TEKNOLOGIKOA</a:t>
             </a:r>
           </a:p>
         </p:txBody>
@@ -6591,7 +6591,7 @@
               </a:defRPr>
             </a:pPr>
             <a:r>
-              <a:t>DISEÑO Y ALCANCE</a:t>
+              <a:t>DISEINUA ETA IRISMENA</a:t>
             </a:r>
           </a:p>
         </p:txBody>
@@ -6773,7 +6773,7 @@
               </a:defRPr>
             </a:pPr>
             <a:r>
-              <a:t>CNC GUARD / PROPUESTA TECNOLÓGICA</a:t>
+              <a:t>CNC GUARD / PROPOSAMEN TEKNOLOGIKOA</a:t>
             </a:r>
           </a:p>
         </p:txBody>
@@ -7650,7 +7650,7 @@
               </a:defRPr>
             </a:pPr>
             <a:r>
-              <a:t>CNC GUARD / PROPUESTA TECNOLÓGICA</a:t>
+              <a:t>CNC GUARD / PROPOSAMEN TEKNOLOGIKOA</a:t>
             </a:r>
           </a:p>
         </p:txBody>
@@ -8527,7 +8527,7 @@
               </a:defRPr>
             </a:pPr>
             <a:r>
-              <a:t>CNC GUARD / PROPUESTA TECNOLÓGICA</a:t>
+              <a:t>CNC GUARD / PROPOSAMEN TEKNOLOGIKOA</a:t>
             </a:r>
           </a:p>
         </p:txBody>
@@ -9404,7 +9404,7 @@
               </a:defRPr>
             </a:pPr>
             <a:r>
-              <a:t>CNC GUARD / PROPUESTA TECNOLÓGICA</a:t>
+              <a:t>CNC GUARD / PROPOSAMEN TEKNOLOGIKOA</a:t>
             </a:r>
           </a:p>
         </p:txBody>
@@ -10281,7 +10281,7 @@
               </a:defRPr>
             </a:pPr>
             <a:r>
-              <a:t>CNC GUARD / PROPUESTA TECNOLÓGICA</a:t>
+              <a:t>CNC GUARD / PROPOSAMEN TEKNOLOGIKOA</a:t>
             </a:r>
           </a:p>
         </p:txBody>
@@ -11158,7 +11158,7 @@
               </a:defRPr>
             </a:pPr>
             <a:r>
-              <a:t>CNC GUARD / PROPUESTA TECNOLÓGICA</a:t>
+              <a:t>CNC GUARD / PROPOSAMEN TEKNOLOGIKOA</a:t>
             </a:r>
           </a:p>
         </p:txBody>
@@ -12035,7 +12035,7 @@
               </a:defRPr>
             </a:pPr>
             <a:r>
-              <a:t>CNC GUARD / PROPUESTA TECNOLÓGICA</a:t>
+              <a:t>CNC GUARD / PROPOSAMEN TEKNOLOGIKOA</a:t>
             </a:r>
           </a:p>
         </p:txBody>
@@ -12912,7 +12912,7 @@
               </a:defRPr>
             </a:pPr>
             <a:r>
-              <a:t>CNC GUARD / PROPUESTA TECNOLÓGICA</a:t>
+              <a:t>CNC GUARD / PROPOSAMEN TEKNOLOGIKOA</a:t>
             </a:r>
           </a:p>
         </p:txBody>
@@ -13789,7 +13789,7 @@
               </a:defRPr>
             </a:pPr>
             <a:r>
-              <a:t>CNC GUARD / PROPUESTA TECNOLÓGICA</a:t>
+              <a:t>CNC GUARD / PROPOSAMEN TEKNOLOGIKOA</a:t>
             </a:r>
           </a:p>
         </p:txBody>
@@ -14666,7 +14666,7 @@
               </a:defRPr>
             </a:pPr>
             <a:r>
-              <a:t>CNC GUARD / PROPUESTA TECNOLÓGICA</a:t>
+              <a:t>CNC GUARD / PROPOSAMEN TEKNOLOGIKOA</a:t>
             </a:r>
           </a:p>
         </p:txBody>
@@ -15543,7 +15543,7 @@
               </a:defRPr>
             </a:pPr>
             <a:r>
-              <a:t>CNC GUARD / PROPUESTA TECNOLÓGICA</a:t>
+              <a:t>CNC GUARD / PROPOSAMEN TEKNOLOGIKOA</a:t>
             </a:r>
           </a:p>
         </p:txBody>
@@ -16238,7 +16238,7 @@
               </a:defRPr>
             </a:pPr>
             <a:r>
-              <a:t>DISEÑO Y ALCANCE</a:t>
+              <a:t>DISEINUA ETA IRISMENA</a:t>
             </a:r>
           </a:p>
         </p:txBody>
@@ -16420,7 +16420,7 @@
               </a:defRPr>
             </a:pPr>
             <a:r>
-              <a:t>CNC GUARD / PROPUESTA TECNOLÓGICA</a:t>
+              <a:t>CNC GUARD / PROPOSAMEN TEKNOLOGIKOA</a:t>
             </a:r>
           </a:p>
         </p:txBody>
@@ -17297,7 +17297,7 @@
               </a:defRPr>
             </a:pPr>
             <a:r>
-              <a:t>CNC GUARD / PROPUESTA TECNOLÓGICA</a:t>
+              <a:t>CNC GUARD / PROPOSAMEN TEKNOLOGIKOA</a:t>
             </a:r>
           </a:p>
         </p:txBody>
@@ -18174,7 +18174,7 @@
               </a:defRPr>
             </a:pPr>
             <a:r>
-              <a:t>CNC GUARD / PROPUESTA TECNOLÓGICA</a:t>
+              <a:t>CNC GUARD / PROPOSAMEN TEKNOLOGIKOA</a:t>
             </a:r>
           </a:p>
         </p:txBody>
@@ -19051,7 +19051,7 @@
               </a:defRPr>
             </a:pPr>
             <a:r>
-              <a:t>CNC GUARD / PROPUESTA TECNOLÓGICA</a:t>
+              <a:t>CNC GUARD / PROPOSAMEN TEKNOLOGIKOA</a:t>
             </a:r>
           </a:p>
         </p:txBody>
@@ -19746,7 +19746,7 @@
               </a:defRPr>
             </a:pPr>
             <a:r>
-              <a:t>DISEÑO Y ALCANCE</a:t>
+              <a:t>DISEINUA ETA IRISMENA</a:t>
             </a:r>
           </a:p>
         </p:txBody>
@@ -19928,7 +19928,7 @@
               </a:defRPr>
             </a:pPr>
             <a:r>
-              <a:t>CNC GUARD / PROPUESTA TECNOLÓGICA</a:t>
+              <a:t>CNC GUARD / PROPOSAMEN TEKNOLOGIKOA</a:t>
             </a:r>
           </a:p>
         </p:txBody>
@@ -20623,7 +20623,7 @@
               </a:defRPr>
             </a:pPr>
             <a:r>
-              <a:t>DISEÑO Y ALCANCE</a:t>
+              <a:t>DISEINUA ETA IRISMENA</a:t>
             </a:r>
           </a:p>
         </p:txBody>
@@ -20805,7 +20805,7 @@
               </a:defRPr>
             </a:pPr>
             <a:r>
-              <a:t>CNC GUARD / PROPUESTA TECNOLÓGICA</a:t>
+              <a:t>CNC GUARD / PROPOSAMEN TEKNOLOGIKOA</a:t>
             </a:r>
           </a:p>
         </p:txBody>
@@ -21500,7 +21500,7 @@
               </a:defRPr>
             </a:pPr>
             <a:r>
-              <a:t>DISEÑO Y ALCANCE</a:t>
+              <a:t>DISEINUA ETA IRISMENA</a:t>
             </a:r>
           </a:p>
         </p:txBody>
@@ -21682,7 +21682,7 @@
               </a:defRPr>
             </a:pPr>
             <a:r>
-              <a:t>CNC GUARD / PROPUESTA TECNOLÓGICA</a:t>
+              <a:t>CNC GUARD / PROPOSAMEN TEKNOLOGIKOA</a:t>
             </a:r>
           </a:p>
         </p:txBody>
@@ -22377,7 +22377,7 @@
               </a:defRPr>
             </a:pPr>
             <a:r>
-              <a:t>DISEÑO Y ALCANCE</a:t>
+              <a:t>DISEINUA ETA IRISMENA</a:t>
             </a:r>
           </a:p>
         </p:txBody>
@@ -22559,7 +22559,7 @@
               </a:defRPr>
             </a:pPr>
             <a:r>
-              <a:t>CNC GUARD / PROPUESTA TECNOLÓGICA</a:t>
+              <a:t>CNC GUARD / PROPOSAMEN TEKNOLOGIKOA</a:t>
             </a:r>
           </a:p>
         </p:txBody>
@@ -23254,7 +23254,7 @@
               </a:defRPr>
             </a:pPr>
             <a:r>
-              <a:t>DISEÑO Y ALCANCE</a:t>
+              <a:t>DISEINUA ETA IRISMENA</a:t>
             </a:r>
           </a:p>
         </p:txBody>
@@ -23436,7 +23436,7 @@
               </a:defRPr>
             </a:pPr>
             <a:r>
-              <a:t>CNC GUARD / PROPUESTA TECNOLÓGICA</a:t>
+              <a:t>CNC GUARD / PROPOSAMEN TEKNOLOGIKOA</a:t>
             </a:r>
           </a:p>
         </p:txBody>
@@ -24131,7 +24131,7 @@
               </a:defRPr>
             </a:pPr>
             <a:r>
-              <a:t>DISEÑO Y ALCANCE</a:t>
+              <a:t>DISEINUA ETA IRISMENA</a:t>
             </a:r>
           </a:p>
         </p:txBody>
@@ -24313,7 +24313,7 @@
               </a:defRPr>
             </a:pPr>
             <a:r>
-              <a:t>CNC GUARD / PROPUESTA TECNOLÓGICA</a:t>
+              <a:t>CNC GUARD / PROPOSAMEN TEKNOLOGIKOA</a:t>
             </a:r>
           </a:p>
         </p:txBody>
@@ -25008,7 +25008,7 @@
               </a:defRPr>
             </a:pPr>
             <a:r>
-              <a:t>DISEÑO Y ALCANCE</a:t>
+              <a:t>DISEINUA ETA IRISMENA</a:t>
             </a:r>
           </a:p>
         </p:txBody>
@@ -25190,7 +25190,7 @@
               </a:defRPr>
             </a:pPr>
             <a:r>
-              <a:t>CNC GUARD / PROPUESTA TECNOLÓGICA</a:t>
+              <a:t>CNC GUARD / PROPOSAMEN TEKNOLOGIKOA</a:t>
             </a:r>
           </a:p>
         </p:txBody>
@@ -25885,7 +25885,7 @@
               </a:defRPr>
             </a:pPr>
             <a:r>
-              <a:t>DISEÑO Y ALCANCE</a:t>
+              <a:t>DISEINUA ETA IRISMENA</a:t>
             </a:r>
           </a:p>
         </p:txBody>
@@ -26067,7 +26067,7 @@
               </a:defRPr>
             </a:pPr>
             <a:r>
-              <a:t>CNC GUARD / PROPUESTA TECNOLÓGICA</a:t>
+              <a:t>CNC GUARD / PROPOSAMEN TEKNOLOGIKOA</a:t>
             </a:r>
           </a:p>
         </p:txBody>
@@ -27436,7 +27436,7 @@
               </a:defRPr>
             </a:pPr>
             <a:r>
-              <a:t>CNC GUARD / PROPUESTA TECNOLÓGICA</a:t>
+              <a:t>CNC GUARD / PROPOSAMEN TEKNOLOGIKOA</a:t>
             </a:r>
           </a:p>
         </p:txBody>
@@ -28805,7 +28805,7 @@
               </a:defRPr>
             </a:pPr>
             <a:r>
-              <a:t>CNC GUARD / PROPUESTA TECNOLÓGICA</a:t>
+              <a:t>CNC GUARD / PROPOSAMEN TEKNOLOGIKOA</a:t>
             </a:r>
           </a:p>
         </p:txBody>
@@ -30010,7 +30010,7 @@
               </a:defRPr>
             </a:pPr>
             <a:r>
-              <a:t>CNC GUARD / PROPUESTA TECNOLÓGICA</a:t>
+              <a:t>CNC GUARD / PROPOSAMEN TEKNOLOGIKOA</a:t>
             </a:r>
           </a:p>
         </p:txBody>
@@ -30705,7 +30705,7 @@
               </a:defRPr>
             </a:pPr>
             <a:r>
-              <a:t>DISEÑO Y ALCANCE</a:t>
+              <a:t>DISEINUA ETA IRISMENA</a:t>
             </a:r>
           </a:p>
         </p:txBody>
@@ -30887,7 +30887,7 @@
               </a:defRPr>
             </a:pPr>
             <a:r>
-              <a:t>CNC GUARD / PROPUESTA TECNOLÓGICA</a:t>
+              <a:t>CNC GUARD / PROPOSAMEN TEKNOLOGIKOA</a:t>
             </a:r>
           </a:p>
         </p:txBody>
@@ -31582,7 +31582,7 @@
               </a:defRPr>
             </a:pPr>
             <a:r>
-              <a:t>DISEÑO Y ALCANCE</a:t>
+              <a:t>DISEINUA ETA IRISMENA</a:t>
             </a:r>
           </a:p>
         </p:txBody>
@@ -31764,7 +31764,7 @@
               </a:defRPr>
             </a:pPr>
             <a:r>
-              <a:t>CNC GUARD / PROPUESTA TECNOLÓGICA</a:t>
+              <a:t>CNC GUARD / PROPOSAMEN TEKNOLOGIKOA</a:t>
             </a:r>
           </a:p>
         </p:txBody>
@@ -32641,7 +32641,7 @@
               </a:defRPr>
             </a:pPr>
             <a:r>
-              <a:t>CNC GUARD / PROPUESTA TECNOLÓGICA</a:t>
+              <a:t>CNC GUARD / PROPOSAMEN TEKNOLOGIKOA</a:t>
             </a:r>
           </a:p>
         </p:txBody>
@@ -33518,7 +33518,7 @@
               </a:defRPr>
             </a:pPr>
             <a:r>
-              <a:t>CNC GUARD / PROPUESTA TECNOLÓGICA</a:t>
+              <a:t>CNC GUARD / PROPOSAMEN TEKNOLOGIKOA</a:t>
             </a:r>
           </a:p>
         </p:txBody>
@@ -34395,7 +34395,7 @@
               </a:defRPr>
             </a:pPr>
             <a:r>
-              <a:t>CNC GUARD / PROPUESTA TECNOLÓGICA</a:t>
+              <a:t>CNC GUARD / PROPOSAMEN TEKNOLOGIKOA</a:t>
             </a:r>
           </a:p>
         </p:txBody>
@@ -35272,7 +35272,7 @@
               </a:defRPr>
             </a:pPr>
             <a:r>
-              <a:t>CNC GUARD / PROPUESTA TECNOLÓGICA</a:t>
+              <a:t>CNC GUARD / PROPOSAMEN TEKNOLOGIKOA</a:t>
             </a:r>
           </a:p>
         </p:txBody>

</xml_diff>